<commit_message>
Fix PowerPoint repair prompt: make chart XML schema-valid
pptxgenjs wrote empty numeric points (<c:v></c:v>) for the stage-split
b* vs mmpy scatter, placed per-point <c:dPt> after <c:dLbls> in the
single-series bar charts, and left category-axis-only elements on
scatter value axes. Post-process each chart part so all 11 charts
validate against dml-chart.xsd.

Co-Authored-By: Claude Opus 5.5 <noreply@anthropic.com>
Claude-Session: https://claude.ai/code/session_0183EH8Ko18ruxKRtBG8bGv1
</commit_message>
<xml_diff>
--- a/ICIMC2026_Woo_colorimetry.pptx
+++ b/ICIMC2026_Woo_colorimetry.pptx
@@ -486,21 +486,6 @@
                 <c:pt idx="3">
                   <c:v>0.406</c:v>
                 </c:pt>
-                <c:pt idx="4">
-                  <c:v/>
-                </c:pt>
-                <c:pt idx="5">
-                  <c:v/>
-                </c:pt>
-                <c:pt idx="6">
-                  <c:v/>
-                </c:pt>
-                <c:pt idx="7">
-                  <c:v/>
-                </c:pt>
-                <c:pt idx="8">
-                  <c:v/>
-                </c:pt>
               </c:numCache>
             </c:numRef>
           </c:yVal>
@@ -588,32 +573,11 @@
               <c:numCache>
                 <c:formatCode>General</c:formatCode>
                 <c:ptCount val="9"/>
-                <c:pt idx="0">
-                  <c:v/>
-                </c:pt>
-                <c:pt idx="1">
-                  <c:v/>
-                </c:pt>
-                <c:pt idx="2">
-                  <c:v/>
-                </c:pt>
-                <c:pt idx="3">
-                  <c:v/>
-                </c:pt>
                 <c:pt idx="4">
                   <c:v>0.524</c:v>
                 </c:pt>
                 <c:pt idx="5">
                   <c:v>0.838</c:v>
-                </c:pt>
-                <c:pt idx="6">
-                  <c:v/>
-                </c:pt>
-                <c:pt idx="7">
-                  <c:v/>
-                </c:pt>
-                <c:pt idx="8">
-                  <c:v/>
                 </c:pt>
               </c:numCache>
             </c:numRef>
@@ -702,24 +666,6 @@
               <c:numCache>
                 <c:formatCode>General</c:formatCode>
                 <c:ptCount val="9"/>
-                <c:pt idx="0">
-                  <c:v/>
-                </c:pt>
-                <c:pt idx="1">
-                  <c:v/>
-                </c:pt>
-                <c:pt idx="2">
-                  <c:v/>
-                </c:pt>
-                <c:pt idx="3">
-                  <c:v/>
-                </c:pt>
-                <c:pt idx="4">
-                  <c:v/>
-                </c:pt>
-                <c:pt idx="5">
-                  <c:v/>
-                </c:pt>
                 <c:pt idx="6">
                   <c:v>1.176</c:v>
                 </c:pt>
@@ -828,9 +774,6 @@
         </c:txPr>
         <c:crossAx val="2094734552"/>
         <c:crosses val="autoZero"/>
-        <c:auto val="1"/>
-        <c:lblAlgn val="ctr"/>
-        <c:noMultiLvlLbl val="1"/>
         <c:majorUnit val="2"/>
       </c:valAx>
       <c:valAx>
@@ -1525,9 +1468,6 @@
         </c:txPr>
         <c:crossAx val="2094734552"/>
         <c:crosses val="autoZero"/>
-        <c:auto val="1"/>
-        <c:lblAlgn val="ctr"/>
-        <c:noMultiLvlLbl val="1"/>
         <c:majorUnit val="5"/>
       </c:valAx>
       <c:valAx>
@@ -1986,9 +1926,6 @@
         </c:txPr>
         <c:crossAx val="2094734552"/>
         <c:crosses val="autoZero"/>
-        <c:auto val="1"/>
-        <c:lblAlgn val="ctr"/>
-        <c:noMultiLvlLbl val="1"/>
         <c:majorUnit val="5"/>
       </c:valAx>
       <c:valAx>
@@ -2329,9 +2266,6 @@
         </c:txPr>
         <c:crossAx val="2094734552"/>
         <c:crosses val="autoZero"/>
-        <c:auto val="1"/>
-        <c:lblAlgn val="ctr"/>
-        <c:noMultiLvlLbl val="1"/>
         <c:majorUnit val="5"/>
       </c:valAx>
       <c:valAx>
@@ -2672,9 +2606,6 @@
         </c:txPr>
         <c:crossAx val="2094734552"/>
         <c:crosses val="autoZero"/>
-        <c:auto val="1"/>
-        <c:lblAlgn val="ctr"/>
-        <c:noMultiLvlLbl val="1"/>
         <c:majorUnit val="5"/>
       </c:valAx>
       <c:valAx>
@@ -2815,30 +2746,6 @@
             <a:effectLst/>
           </c:spPr>
           <c:invertIfNegative val="0"/>
-          <c:dLbls>
-            <c:numFmt formatCode="0.0" sourceLinked="0"/>
-            <c:txPr>
-              <a:bodyPr/>
-              <a:lstStyle/>
-              <a:p>
-                <a:pPr>
-                  <a:defRPr b="1" i="0" strike="noStrike" sz="1400" u="none">
-                    <a:solidFill>
-                      <a:srgbClr val="2B2D31"/>
-                    </a:solidFill>
-                    <a:latin typeface="Arial"/>
-                  </a:defRPr>
-                </a:pPr>
-              </a:p>
-            </c:txPr>
-            <c:showLegendKey val="0"/>
-            <c:showVal val="1"/>
-            <c:showCatName val="0"/>
-            <c:showSerName val="0"/>
-            <c:showPercent val="0"/>
-            <c:showBubbleSize val="0"/>
-            <c:showLeaderLines val="0"/>
-          </c:dLbls>
           <c:dPt>
             <c:idx val="0"/>
             <c:invertIfNegative val="0"/>
@@ -2894,6 +2801,30 @@
               <a:effectLst/>
             </c:spPr>
           </c:dPt>
+          <c:dLbls>
+            <c:numFmt formatCode="0.0" sourceLinked="0"/>
+            <c:txPr>
+              <a:bodyPr/>
+              <a:lstStyle/>
+              <a:p>
+                <a:pPr>
+                  <a:defRPr b="1" i="0" strike="noStrike" sz="1400" u="none">
+                    <a:solidFill>
+                      <a:srgbClr val="2B2D31"/>
+                    </a:solidFill>
+                    <a:latin typeface="Arial"/>
+                  </a:defRPr>
+                </a:pPr>
+              </a:p>
+            </c:txPr>
+            <c:showLegendKey val="0"/>
+            <c:showVal val="1"/>
+            <c:showCatName val="0"/>
+            <c:showSerName val="0"/>
+            <c:showPercent val="0"/>
+            <c:showBubbleSize val="0"/>
+            <c:showLeaderLines val="0"/>
+          </c:dLbls>
           <c:cat>
             <c:multiLvlStrRef>
               <c:f>Sheet1!$A$2:$A$6</c:f>
@@ -2972,7 +2903,6 @@
         <c:overlap val="0"/>
         <c:axId val="2094734554"/>
         <c:axId val="2094734552"/>
-        <c:axId val="2094734556"/>
       </c:barChart>
       <c:catAx>
         <c:axId val="2094734554"/>
@@ -3323,9 +3253,6 @@
         </c:txPr>
         <c:crossAx val="2094734552"/>
         <c:crosses val="autoZero"/>
-        <c:auto val="1"/>
-        <c:lblAlgn val="ctr"/>
-        <c:noMultiLvlLbl val="1"/>
         <c:majorUnit val="5"/>
       </c:valAx>
       <c:valAx>
@@ -3784,9 +3711,6 @@
         </c:txPr>
         <c:crossAx val="2094734552"/>
         <c:crosses val="autoZero"/>
-        <c:auto val="1"/>
-        <c:lblAlgn val="ctr"/>
-        <c:noMultiLvlLbl val="1"/>
         <c:majorUnit val="5"/>
       </c:valAx>
       <c:valAx>
@@ -4100,7 +4024,6 @@
         <c:overlap val="0"/>
         <c:axId val="2094734554"/>
         <c:axId val="2094734552"/>
-        <c:axId val="2094734556"/>
       </c:barChart>
       <c:catAx>
         <c:axId val="2094734554"/>
@@ -4251,30 +4174,6 @@
             <a:effectLst/>
           </c:spPr>
           <c:invertIfNegative val="0"/>
-          <c:dLbls>
-            <c:numFmt formatCode="0.000;−0.000" sourceLinked="0"/>
-            <c:txPr>
-              <a:bodyPr/>
-              <a:lstStyle/>
-              <a:p>
-                <a:pPr>
-                  <a:defRPr b="1" i="0" strike="noStrike" sz="1400" u="none">
-                    <a:solidFill>
-                      <a:srgbClr val="2B2D31"/>
-                    </a:solidFill>
-                    <a:latin typeface="Arial"/>
-                  </a:defRPr>
-                </a:pPr>
-              </a:p>
-            </c:txPr>
-            <c:showLegendKey val="0"/>
-            <c:showVal val="1"/>
-            <c:showCatName val="0"/>
-            <c:showSerName val="0"/>
-            <c:showPercent val="0"/>
-            <c:showBubbleSize val="0"/>
-            <c:showLeaderLines val="0"/>
-          </c:dLbls>
           <c:dPt>
             <c:idx val="0"/>
             <c:invertIfNegative val="0"/>
@@ -4308,6 +4207,30 @@
               <a:effectLst/>
             </c:spPr>
           </c:dPt>
+          <c:dLbls>
+            <c:numFmt formatCode="0.000;−0.000" sourceLinked="0"/>
+            <c:txPr>
+              <a:bodyPr/>
+              <a:lstStyle/>
+              <a:p>
+                <a:pPr>
+                  <a:defRPr b="1" i="0" strike="noStrike" sz="1400" u="none">
+                    <a:solidFill>
+                      <a:srgbClr val="2B2D31"/>
+                    </a:solidFill>
+                    <a:latin typeface="Arial"/>
+                  </a:defRPr>
+                </a:pPr>
+              </a:p>
+            </c:txPr>
+            <c:showLegendKey val="0"/>
+            <c:showVal val="1"/>
+            <c:showCatName val="0"/>
+            <c:showSerName val="0"/>
+            <c:showPercent val="0"/>
+            <c:showBubbleSize val="0"/>
+            <c:showLeaderLines val="0"/>
+          </c:dLbls>
           <c:cat>
             <c:multiLvlStrRef>
               <c:f>Sheet1!$A$2:$A$4</c:f>
@@ -4374,7 +4297,6 @@
         <c:overlap val="0"/>
         <c:axId val="2094734554"/>
         <c:axId val="2094734552"/>
-        <c:axId val="2094734556"/>
       </c:barChart>
       <c:catAx>
         <c:axId val="2094734554"/>

</xml_diff>